<commit_message>
Add 4 sets (no prices), draft Heineken, tax-included footer, sets PPTX
- Beer/Draft: add Heineken 16,500 (master price)
- Footer -> "НӨАТ болон хотын татвар багтсан" / "VAT & city tax included"
  (index.html is shared, so this applies to the master menu too)
- New "Сэт цэс" category with 4 sets prepared from handwritten notes,
  contents + quantities only, no prices yet (Pricing coming soon). Renderer
  supports set groups without a total.
- Махан цуглуулга = standalone restaurant dish; Set 3 Alkaline = 6 (per owner)
- Regenerate print/C-Garden-Menu-A4.pptx (footer + Heineken)
- New print/C-Garden-Sets-halfA4.pptx: 4 sets on half an A4 sheet
- Bump assets to v=10

Co-Authored-By: Claude Opus 4.8 <noreply@anthropic.com>
Claude-Session: https://claude.ai/code/session_01TnVy1C21x68ctXsvvdvyLV
</commit_message>
<xml_diff>
--- a/print/C-Garden-Menu-A4.pptx
+++ b/print/C-Garden-Menu-A4.pptx
@@ -3148,7 +3148,7 @@
         </p:blipFill>
         <p:spPr>
           <a:xfrm>
-            <a:off x="2729484" y="411480"/>
+            <a:off x="2729484" y="164592"/>
             <a:ext cx="2103120" cy="1752600"/>
           </a:xfrm>
           <a:prstGeom prst="rect">
@@ -3164,7 +3164,7 @@
         </p:nvSpPr>
         <p:spPr>
           <a:xfrm>
-            <a:off x="0" y="2331720"/>
+            <a:off x="0" y="2286000"/>
             <a:ext cx="7562088" cy="365760"/>
           </a:xfrm>
           <a:prstGeom prst="rect">
@@ -3173,7 +3173,7 @@
           <a:noFill/>
         </p:spPr>
         <p:txBody>
-          <a:bodyPr wrap="square">
+          <a:bodyPr wrap="none">
             <a:spAutoFit/>
           </a:bodyPr>
           <a:lstStyle/>
@@ -3214,9 +3214,6 @@
           <a:lstStyle/>
           <a:p>
             <a:pPr>
-              <a:spcBef>
-                <a:spcPts val="1400"/>
-              </a:spcBef>
               <a:spcAft>
                 <a:spcPts val="200"/>
               </a:spcAft>
@@ -3358,6 +3355,37 @@
           <a:p>
             <a:pPr>
               <a:spcBef>
+                <a:spcPts val="300"/>
+              </a:spcBef>
+              <a:spcAft>
+                <a:spcPts val="0"/>
+              </a:spcAft>
+              <a:tabLst>
+                <a:tab pos="3200400" algn="r"/>
+              </a:tabLst>
+            </a:pPr>
+            <a:r>
+              <a:rPr sz="1150">
+                <a:solidFill>
+                  <a:srgbClr val="242C26"/>
+                </a:solidFill>
+                <a:latin typeface="Arial"/>
+              </a:rPr>
+              <a:t>Heineken</a:t>
+            </a:r>
+            <a:r>
+              <a:rPr sz="1150" b="1">
+                <a:solidFill>
+                  <a:srgbClr val="9C7A2E"/>
+                </a:solidFill>
+                <a:latin typeface="Georgia"/>
+              </a:rPr>
+              <a:t>	16,500₮</a:t>
+            </a:r>
+          </a:p>
+          <a:p>
+            <a:pPr>
+              <a:spcBef>
                 <a:spcPts val="700"/>
               </a:spcBef>
               <a:spcAft>
@@ -3951,9 +3979,6 @@
           <a:lstStyle/>
           <a:p>
             <a:pPr>
-              <a:spcBef>
-                <a:spcPts val="1400"/>
-              </a:spcBef>
               <a:spcAft>
                 <a:spcPts val="200"/>
               </a:spcAft>
@@ -4531,8 +4556,8 @@
         </p:nvSpPr>
         <p:spPr>
           <a:xfrm>
-            <a:off x="457200" y="10058400"/>
-            <a:ext cx="6647688" cy="411480"/>
+            <a:off x="457200" y="10104120"/>
+            <a:ext cx="6647688" cy="365760"/>
           </a:xfrm>
           <a:prstGeom prst="rect">
             <a:avLst/>
@@ -4540,7 +4565,7 @@
           <a:noFill/>
         </p:spPr>
         <p:txBody>
-          <a:bodyPr wrap="square">
+          <a:bodyPr wrap="none">
             <a:spAutoFit/>
           </a:bodyPr>
           <a:lstStyle/>
@@ -4553,7 +4578,7 @@
                 </a:solidFill>
                 <a:latin typeface="Arial"/>
               </a:rPr>
-              <a:t>Бүх үнэ ₮.  НӨАТ 10% ба хотын татвар 2% ороогүй.</a:t>
+              <a:t>Бүх үнэ ₮.  НӨАТ болон хотын татвар багтсан.</a:t>
             </a:r>
           </a:p>
         </p:txBody>

</xml_diff>